<commit_message>
docs(TASK-007): test count 157 after #19
</commit_message>
<xml_diff>
--- a/submission/TraceGuard-proposal.pptx
+++ b/submission/TraceGuard-proposal.pptx
@@ -8586,7 +8586,7 @@
                 </a:solidFill>
                 <a:latin typeface="Google Sans Flex"/>
               </a:rPr>
-              <a:t>default thinking 20–28 s per brief (one 504 at the 30 s cap) → LOW thinking 3–9 s, all valid. 156 automated tests; mypy strict. </a:t>
+              <a:t>default thinking 20–28 s per brief (one 504 at the 30 s cap) → LOW thinking 3–9 s, all valid. 157 automated tests; mypy strict. </a:t>
             </a:r>
             <a:r>
               <a:rPr sz="950" i="1">
@@ -18287,7 +18287,7 @@
                           </a:solidFill>
                           <a:latin typeface="Google Sans Flex"/>
                         </a:rPr>
-                        <a:t>pytest (156 tests) · mypy strict</a:t>
+                        <a:t>pytest (157 tests) · mypy strict</a:t>
                       </a:r>
                     </a:p>
                   </a:txBody>

</xml_diff>

<commit_message>
docs(TASK-007): deck, script and screenshots for the new UI (#20-#22)
Screenshots retaken on the side-by-side layout with the Verified panel and
follow-up question. Slide 4 adds the follow-up question; slide 6 callouts
match the new layout; slide 10 shows citation highlight, the full
Verified panel and an honest follow-up refusal; slide 12 drops the
now-built follow-up from future work; test count 168. Video script's
1:20-2:15 section covers verification and the follow-up refusal.
</commit_message>
<xml_diff>
--- a/submission/TraceGuard-proposal.pptx
+++ b/submission/TraceGuard-proposal.pptx
@@ -7267,7 +7267,7 @@
         </p:nvPicPr>
         <p:blipFill>
           <a:blip r:embed="rId5"/>
-          <a:srcRect l="25500" t="62000" r="5000" b="2000"/>
+          <a:srcRect l="25500" t="39000" r="40000"/>
           <a:stretch>
             <a:fillRect/>
           </a:stretch>
@@ -7275,7 +7275,7 @@
         <p:spPr>
           <a:xfrm>
             <a:off x="320040" y="1188720"/>
-            <a:ext cx="4572000" cy="1578820"/>
+            <a:ext cx="2094500" cy="2468880"/>
           </a:xfrm>
           <a:prstGeom prst="rect">
             <a:avLst/>
@@ -7287,9 +7287,57 @@
           </a:ln>
         </p:spPr>
       </p:pic>
+      <p:sp>
+        <p:nvSpPr>
+          <p:cNvPr id="129" name="TextBox 128"/>
+          <p:cNvSpPr txBox="1"/>
+          <p:nvPr/>
+        </p:nvSpPr>
+        <p:spPr>
+          <a:xfrm>
+            <a:off x="320040" y="3730752"/>
+            <a:ext cx="2094500" cy="685800"/>
+          </a:xfrm>
+          <a:prstGeom prst="rect">
+            <a:avLst/>
+          </a:prstGeom>
+          <a:noFill/>
+        </p:spPr>
+        <p:txBody>
+          <a:bodyPr wrap="square" anchor="t" lIns="36576" rIns="36576" tIns="18288" bIns="18288">
+            <a:spAutoFit/>
+          </a:bodyPr>
+          <a:lstStyle/>
+          <a:p>
+            <a:pPr algn="l">
+              <a:spcAft>
+                <a:spcPts val="400"/>
+              </a:spcAft>
+            </a:pPr>
+            <a:r>
+              <a:rPr sz="1000" i="0">
+                <a:solidFill>
+                  <a:srgbClr val="5F6368"/>
+                </a:solidFill>
+                <a:latin typeface="Google Sans Flex SemiBold"/>
+              </a:rPr>
+              <a:t>Citation click: </a:t>
+            </a:r>
+            <a:r>
+              <a:rPr sz="1000" i="0">
+                <a:solidFill>
+                  <a:srgbClr val="5F6368"/>
+                </a:solidFill>
+                <a:latin typeface="Google Sans Flex"/>
+              </a:rPr>
+              <a:t>records cited by RULE-FWD-01 highlighted on the graph (amber).</a:t>
+            </a:r>
+          </a:p>
+        </p:txBody>
+      </p:sp>
       <p:pic>
         <p:nvPicPr>
-          <p:cNvPr id="129" name="Picture 128" descr="slide3-citation-records.png"/>
+          <p:cNvPr id="130" name="Picture 129" descr="slide10-verified-panel.png"/>
           <p:cNvPicPr>
             <a:picLocks noChangeAspect="1"/>
           </p:cNvPicPr>
@@ -7297,15 +7345,15 @@
         </p:nvPicPr>
         <p:blipFill>
           <a:blip r:embed="rId6"/>
-          <a:srcRect l="25500" r="5000" b="55000"/>
+          <a:srcRect r="5000"/>
           <a:stretch>
             <a:fillRect/>
           </a:stretch>
         </p:blipFill>
         <p:spPr>
           <a:xfrm>
-            <a:off x="320040" y="2831548"/>
-            <a:ext cx="4572000" cy="1973525"/>
+            <a:off x="2551700" y="1188720"/>
+            <a:ext cx="3479063" cy="2468880"/>
           </a:xfrm>
           <a:prstGeom prst="rect">
             <a:avLst/>
@@ -7317,9 +7365,57 @@
           </a:ln>
         </p:spPr>
       </p:pic>
+      <p:sp>
+        <p:nvSpPr>
+          <p:cNvPr id="131" name="TextBox 130"/>
+          <p:cNvSpPr txBox="1"/>
+          <p:nvPr/>
+        </p:nvSpPr>
+        <p:spPr>
+          <a:xfrm>
+            <a:off x="2551700" y="3730752"/>
+            <a:ext cx="3479063" cy="685800"/>
+          </a:xfrm>
+          <a:prstGeom prst="rect">
+            <a:avLst/>
+          </a:prstGeom>
+          <a:noFill/>
+        </p:spPr>
+        <p:txBody>
+          <a:bodyPr wrap="square" anchor="t" lIns="36576" rIns="36576" tIns="18288" bIns="18288">
+            <a:spAutoFit/>
+          </a:bodyPr>
+          <a:lstStyle/>
+          <a:p>
+            <a:pPr algn="l">
+              <a:spcAft>
+                <a:spcPts val="400"/>
+              </a:spcAft>
+            </a:pPr>
+            <a:r>
+              <a:rPr sz="1000" i="0">
+                <a:solidFill>
+                  <a:srgbClr val="5F6368"/>
+                </a:solidFill>
+                <a:latin typeface="Google Sans Flex SemiBold"/>
+              </a:rPr>
+              <a:t>Verified before display: </a:t>
+            </a:r>
+            <a:r>
+              <a:rPr sz="1000" i="0">
+                <a:solidFill>
+                  <a:srgbClr val="5F6368"/>
+                </a:solidFill>
+                <a:latin typeface="Google Sans Flex"/>
+              </a:rPr>
+              <a:t>citations, figures and wording checked, shown beside the brief.</a:t>
+            </a:r>
+          </a:p>
+        </p:txBody>
+      </p:sp>
       <p:pic>
         <p:nvPicPr>
-          <p:cNvPr id="130" name="Picture 129" descr="slide3-graph-highlight.png"/>
+          <p:cNvPr id="132" name="Picture 131" descr="slide10-follow-up-refusal.png"/>
           <p:cNvPicPr>
             <a:picLocks noChangeAspect="1"/>
           </p:cNvPicPr>
@@ -7327,15 +7423,15 @@
         </p:nvPicPr>
         <p:blipFill>
           <a:blip r:embed="rId7"/>
-          <a:srcRect l="32000" t="17000" r="25000" b="17000"/>
+          <a:srcRect l="63500" t="55000" r="5000"/>
           <a:stretch>
             <a:fillRect/>
           </a:stretch>
         </p:blipFill>
         <p:spPr>
           <a:xfrm>
-            <a:off x="5257800" y="1188720"/>
-            <a:ext cx="3108960" cy="3181261"/>
+            <a:off x="6167923" y="1188720"/>
+            <a:ext cx="2592324" cy="2468880"/>
           </a:xfrm>
           <a:prstGeom prst="rect">
             <a:avLst/>
@@ -7349,14 +7445,14 @@
       </p:pic>
       <p:sp>
         <p:nvSpPr>
-          <p:cNvPr id="131" name="TextBox 130"/>
+          <p:cNvPr id="133" name="TextBox 132"/>
           <p:cNvSpPr txBox="1"/>
           <p:nvPr/>
         </p:nvSpPr>
         <p:spPr>
           <a:xfrm>
-            <a:off x="5120640" y="4424845"/>
-            <a:ext cx="3703320" cy="822960"/>
+            <a:off x="6167923" y="3730752"/>
+            <a:ext cx="2592324" cy="685800"/>
           </a:xfrm>
           <a:prstGeom prst="rect">
             <a:avLst/>
@@ -7371,51 +7467,26 @@
           <a:p>
             <a:pPr algn="l">
               <a:spcAft>
-                <a:spcPts val="200"/>
-              </a:spcAft>
-            </a:pPr>
-            <a:r>
-              <a:rPr sz="950" i="0">
+                <a:spcPts val="400"/>
+              </a:spcAft>
+            </a:pPr>
+            <a:r>
+              <a:rPr sz="1000" i="0">
                 <a:solidFill>
                   <a:srgbClr val="5F6368"/>
                 </a:solidFill>
                 <a:latin typeface="Google Sans Flex SemiBold"/>
               </a:rPr>
-              <a:t>Left: </a:t>
-            </a:r>
-            <a:r>
-              <a:rPr sz="950" i="0">
+              <a:t>Follow-up question: </a:t>
+            </a:r>
+            <a:r>
+              <a:rPr sz="1000" i="0">
                 <a:solidFill>
                   <a:srgbClr val="5F6368"/>
                 </a:solidFill>
                 <a:latin typeface="Google Sans Flex"/>
               </a:rPr>
-              <a:t>live brief on real graph evidence: rule flags with thresholds, computed contrasts, then Gemini's counterevidence and unknowns.</a:t>
-            </a:r>
-          </a:p>
-          <a:p>
-            <a:pPr algn="l">
-              <a:spcAft>
-                <a:spcPts val="200"/>
-              </a:spcAft>
-            </a:pPr>
-            <a:r>
-              <a:rPr sz="950" i="0">
-                <a:solidFill>
-                  <a:srgbClr val="5F6368"/>
-                </a:solidFill>
-                <a:latin typeface="Google Sans Flex SemiBold"/>
-              </a:rPr>
-              <a:t>Right: </a:t>
-            </a:r>
-            <a:r>
-              <a:rPr sz="950" i="0">
-                <a:solidFill>
-                  <a:srgbClr val="5F6368"/>
-                </a:solidFill>
-                <a:latin typeface="Google Sans Flex"/>
-              </a:rPr>
-              <a:t>clicking RULE-FWD-01 highlights the records it matched (amber).</a:t>
+              <a:t>"Who owns A-22?" is refused: the case data can't answer it.</a:t>
             </a:r>
           </a:p>
         </p:txBody>
@@ -8586,7 +8657,7 @@
                 </a:solidFill>
                 <a:latin typeface="Google Sans Flex"/>
               </a:rPr>
-              <a:t>default thinking 20–28 s per brief (one 504 at the 30 s cap) → LOW thinking 3–9 s, all valid. 157 automated tests; mypy strict. </a:t>
+              <a:t>default thinking 20–28 s per brief (one 504 at the 30 s cap) → LOW thinking 3–9 s, all valid. 168 automated tests; mypy strict. </a:t>
             </a:r>
             <a:r>
               <a:rPr sz="950" i="1">
@@ -9386,7 +9457,7 @@
                 </a:solidFill>
                 <a:latin typeface="Google Sans Flex"/>
               </a:rPr>
-              <a:t>Cycle detection and CSV import (cut from this build); a case-scoped follow-up question with the same citation rules.</a:t>
+              <a:t>Cycle detection, CSV import of the bank's own alerts, and cross-case links between accounts (cut from this build).</a:t>
             </a:r>
           </a:p>
         </p:txBody>
@@ -12390,7 +12461,7 @@
                 </a:solidFill>
                 <a:latin typeface="Google Sans Flex"/>
               </a:rPr>
-              <a:t>Every cited ID and every figure in the brief is validated against tool output. A failing brief is regenerated once, then blocked.</a:t>
+              <a:t>Every cited ID and figure is validated against tool output, and the checks are shown on screen ("Verified before display"). A failing brief is regenerated once, then blocked.</a:t>
             </a:r>
           </a:p>
           <a:p>
@@ -13661,7 +13732,7 @@
                 </a:solidFill>
                 <a:latin typeface="Google Sans Flex SemiBold"/>
               </a:rPr>
-              <a:t>Citation navigation</a:t>
+              <a:t>Citations and export</a:t>
             </a:r>
           </a:p>
           <a:p>
@@ -13677,7 +13748,7 @@
                 </a:solidFill>
                 <a:latin typeface="Google Sans Flex"/>
               </a:rPr>
-              <a:t>Click an evidence ID to highlight its record on graph and timeline</a:t>
+              <a:t>Click an evidence ID to highlight it on the graph; export the brief as Markdown</a:t>
             </a:r>
           </a:p>
         </p:txBody>
@@ -13815,7 +13886,7 @@
                 </a:solidFill>
                 <a:latin typeface="Google Sans Flex SemiBold"/>
               </a:rPr>
-              <a:t>Markdown export</a:t>
+              <a:t>Follow-up question</a:t>
             </a:r>
           </a:p>
           <a:p>
@@ -13831,7 +13902,7 @@
                 </a:solidFill>
                 <a:latin typeface="Google Sans Flex"/>
               </a:rPr>
-              <a:t>Download the brief with model, run time and evidence list</a:t>
+              <a:t>Ask about the case; answered from the same evidence, or refused if it can't be</a:t>
             </a:r>
           </a:p>
         </p:txBody>
@@ -15731,7 +15802,7 @@
         </p:nvSpPr>
         <p:spPr>
           <a:xfrm>
-            <a:off x="1782851" y="2633472"/>
+            <a:off x="1728673" y="2886303"/>
             <a:ext cx="274320" cy="274320"/>
           </a:xfrm>
           <a:prstGeom prst="ellipse">
@@ -15784,7 +15855,7 @@
         </p:nvSpPr>
         <p:spPr>
           <a:xfrm>
-            <a:off x="5223167" y="2488996"/>
+            <a:off x="3543642" y="2633472"/>
             <a:ext cx="274320" cy="274320"/>
           </a:xfrm>
           <a:prstGeom prst="ellipse">
@@ -16293,7 +16364,7 @@
                 </a:solidFill>
                 <a:latin typeface="Google Sans Flex SemiBold"/>
               </a:rPr>
-              <a:t>Selection panel</a:t>
+              <a:t>AI investigation panel</a:t>
             </a:r>
           </a:p>
           <a:p>
@@ -16309,7 +16380,7 @@
                 </a:solidFill>
                 <a:latin typeface="Google Sans Flex"/>
               </a:rPr>
-              <a:t>Click a node to list every record that touches it</a:t>
+              <a:t>Brief, Verified panel and follow-up question, scrolling beside the graph</a:t>
             </a:r>
           </a:p>
         </p:txBody>
@@ -16417,7 +16488,7 @@
                 </a:solidFill>
                 <a:latin typeface="Google Sans Flex"/>
               </a:rPr>
-              <a:t>Timeline, AI investigation, brief, citations, export</a:t>
+              <a:t>Selection panel for the clicked node, then the full timeline</a:t>
             </a:r>
           </a:p>
         </p:txBody>
@@ -18287,7 +18358,7 @@
                           </a:solidFill>
                           <a:latin typeface="Google Sans Flex"/>
                         </a:rPr>
-                        <a:t>pytest (157 tests) · mypy strict</a:t>
+                        <a:t>pytest (168 tests) · mypy strict</a:t>
                       </a:r>
                     </a:p>
                   </a:txBody>

</xml_diff>

<commit_message>
docs(TASK-007): polish the proposal deck for submission
- slide 13: real demo video link (public Drive file) and the portal's "3–4 Minutes" label
- slide 3: "graph tools compute, Gemini explains, the analyst judges" (matches the video)
- slides 8 and 11: one measured latency, 3–9 s at LOW thinking
- slide 7: Google Cloud, Gemini and Vertex AI marks on the architecture
- slide 10: follow-up refusal retaken on C-3, where A-22 actually appears
- slide 2: in -> out -> decision strip; slide 15 closes on the product promise and links
- checklist and screenshot provenance updated; deck passes package validation

Co-Authored-By: Claude Opus 5.5 <noreply@anthropic.com>
</commit_message>
<xml_diff>
--- a/submission/TraceGuard-proposal.pptx
+++ b/submission/TraceGuard-proposal.pptx
@@ -7423,7 +7423,7 @@
         </p:nvPicPr>
         <p:blipFill>
           <a:blip r:embed="rId7"/>
-          <a:srcRect l="63500" t="55000" r="5000"/>
+          <a:srcRect/>
           <a:stretch>
             <a:fillRect/>
           </a:stretch>
@@ -7431,7 +7431,7 @@
         <p:spPr>
           <a:xfrm>
             <a:off x="6167923" y="1188720"/>
-            <a:ext cx="2592324" cy="2468880"/>
+            <a:ext cx="2677915" cy="2468880"/>
           </a:xfrm>
           <a:prstGeom prst="rect">
             <a:avLst/>
@@ -7452,7 +7452,7 @@
         <p:spPr>
           <a:xfrm>
             <a:off x="6167923" y="3730752"/>
-            <a:ext cx="2592324" cy="685800"/>
+            <a:ext cx="2677915" cy="685800"/>
           </a:xfrm>
           <a:prstGeom prst="rect">
             <a:avLst/>
@@ -7477,7 +7477,7 @@
                 </a:solidFill>
                 <a:latin typeface="Google Sans Flex SemiBold"/>
               </a:rPr>
-              <a:t>Follow-up question: </a:t>
+              <a:t>Follow-up on C-3: </a:t>
             </a:r>
             <a:r>
               <a:rPr sz="1000" i="0">
@@ -8026,7 +8026,7 @@
                 </a:solidFill>
                 <a:latin typeface="Google Sans Flex SemiBold"/>
               </a:rPr>
-              <a:t>5–8 s</a:t>
+              <a:t>3–9 s</a:t>
             </a:r>
           </a:p>
         </p:txBody>
@@ -8065,7 +8065,7 @@
                 </a:solidFill>
                 <a:latin typeface="Google Sans Flex"/>
               </a:rPr>
-              <a:t>live brief, valid on the</a:t>
+              <a:t>live brief (LOW thinking),</a:t>
             </a:r>
           </a:p>
           <a:p>
@@ -8081,7 +8081,7 @@
                 </a:solidFill>
                 <a:latin typeface="Google Sans Flex"/>
               </a:rPr>
-              <a:t>first attempt</a:t>
+              <a:t>valid on the first attempt</a:t>
             </a:r>
           </a:p>
         </p:txBody>
@@ -9973,7 +9973,7 @@
                 </a:solidFill>
                 <a:latin typeface="Google Sans Flex SemiBold"/>
               </a:rPr>
-              <a:t>Demo Video Link (3 Minutes)</a:t>
+              <a:t>Demo Video Link (3–4 Minutes)</a:t>
             </a:r>
           </a:p>
           <a:p>
@@ -9988,8 +9988,9 @@
                   <a:srgbClr val="1A73E8"/>
                 </a:solidFill>
                 <a:latin typeface="Google Sans Flex"/>
-              </a:rPr>
-              <a:t>ADD-VIDEO-LINK-BEFORE-SUBMITTING</a:t>
+                <a:hlinkClick r:id="rId6"/>
+              </a:rPr>
+              <a:t>https://drive.google.com/file/d/15qQuek3NzyF3jAUqO0b61K3u1IBdCGOg/view</a:t>
             </a:r>
           </a:p>
         </p:txBody>
@@ -10142,7 +10143,7 @@
                   <a:srgbClr val="1A73E8"/>
                 </a:solidFill>
                 <a:latin typeface="Google Sans Flex"/>
-                <a:hlinkClick r:id="rId6"/>
+                <a:hlinkClick r:id="rId7"/>
               </a:rPr>
               <a:t>https://traceguard-343683630064.asia-southeast1.run.app</a:t>
             </a:r>
@@ -10183,7 +10184,7 @@
                 </a:solidFill>
                 <a:latin typeface="Google Sans Flex"/>
               </a:rPr>
-              <a:t>Live app runs C-1, C-2 and C-3 end to end, including a real Gemini call. No sign-in needed.</a:t>
+              <a:t>Live app runs C-1, C-2 and C-3 end to end, including a real Gemini call. No sign-in needed. Video: 3:56, follows a fictional analyst through the three synthetic cases.</a:t>
             </a:r>
           </a:p>
         </p:txBody>
@@ -10952,6 +10953,134 @@
           </a:ln>
         </p:spPr>
       </p:pic>
+      <p:sp>
+        <p:nvSpPr>
+          <p:cNvPr id="165" name="TextBox 164"/>
+          <p:cNvSpPr txBox="1"/>
+          <p:nvPr/>
+        </p:nvSpPr>
+        <p:spPr>
+          <a:xfrm>
+            <a:off x="6172200" y="2103120"/>
+            <a:ext cx="2743200" cy="2377440"/>
+          </a:xfrm>
+          <a:prstGeom prst="rect">
+            <a:avLst/>
+          </a:prstGeom>
+          <a:noFill/>
+        </p:spPr>
+        <p:txBody>
+          <a:bodyPr wrap="square" anchor="t" lIns="36576" rIns="36576" tIns="18288" bIns="18288">
+            <a:spAutoFit/>
+          </a:bodyPr>
+          <a:lstStyle/>
+          <a:p>
+            <a:pPr algn="l">
+              <a:spcAft>
+                <a:spcPts val="600"/>
+              </a:spcAft>
+            </a:pPr>
+            <a:r>
+              <a:rPr sz="2800" i="0">
+                <a:solidFill>
+                  <a:srgbClr val="FFFFFF"/>
+                </a:solidFill>
+                <a:latin typeface="Google Sans Flex SemiBold"/>
+              </a:rPr>
+              <a:t>Trace</a:t>
+            </a:r>
+            <a:r>
+              <a:rPr sz="2800" i="0">
+                <a:solidFill>
+                  <a:srgbClr val="34A853"/>
+                </a:solidFill>
+                <a:latin typeface="Google Sans Flex SemiBold"/>
+              </a:rPr>
+              <a:t>Guard</a:t>
+            </a:r>
+          </a:p>
+          <a:p>
+            <a:pPr algn="l">
+              <a:spcAft>
+                <a:spcPts val="600"/>
+              </a:spcAft>
+            </a:pPr>
+            <a:r>
+              <a:rPr sz="1500" i="0">
+                <a:solidFill>
+                  <a:srgbClr val="FFFFFF"/>
+                </a:solidFill>
+                <a:latin typeface="Google Sans Flex"/>
+              </a:rPr>
+              <a:t>Follow the connections.</a:t>
+            </a:r>
+          </a:p>
+          <a:p>
+            <a:pPr algn="l">
+              <a:spcAft>
+                <a:spcPts val="600"/>
+              </a:spcAft>
+            </a:pPr>
+            <a:r>
+              <a:rPr sz="1500" i="0">
+                <a:solidFill>
+                  <a:srgbClr val="FFFFFF"/>
+                </a:solidFill>
+                <a:latin typeface="Google Sans Flex"/>
+              </a:rPr>
+              <a:t>Keep the judgment human.</a:t>
+            </a:r>
+          </a:p>
+          <a:p>
+            <a:pPr algn="l">
+              <a:spcAft>
+                <a:spcPts val="600"/>
+              </a:spcAft>
+            </a:pPr>
+            <a:r>
+              <a:rPr sz="1100" i="0">
+                <a:solidFill>
+                  <a:srgbClr val="BDC1C6"/>
+                </a:solidFill>
+                <a:latin typeface="Google Sans Flex"/>
+              </a:rPr>
+              <a:t>Team Chilli · AI Builder Cup 2026</a:t>
+            </a:r>
+          </a:p>
+          <a:p>
+            <a:pPr algn="l">
+              <a:spcAft>
+                <a:spcPts val="600"/>
+              </a:spcAft>
+            </a:pPr>
+            <a:r>
+              <a:rPr sz="1000" i="0">
+                <a:solidFill>
+                  <a:srgbClr val="BDC1C6"/>
+                </a:solidFill>
+                <a:latin typeface="Google Sans Flex"/>
+              </a:rPr>
+              <a:t>traceguard-343683630064.asia-southeast1.run.app</a:t>
+            </a:r>
+          </a:p>
+          <a:p>
+            <a:pPr algn="l">
+              <a:spcAft>
+                <a:spcPts val="600"/>
+              </a:spcAft>
+            </a:pPr>
+            <a:r>
+              <a:rPr sz="1000" i="0">
+                <a:solidFill>
+                  <a:srgbClr val="BDC1C6"/>
+                </a:solidFill>
+                <a:latin typeface="Google Sans Flex"/>
+              </a:rPr>
+              <a:t>github.com/shieryl-ryle/traceguard</a:t>
+            </a:r>
+          </a:p>
+        </p:txBody>
+      </p:sp>
     </p:spTree>
   </p:cSld>
   <p:clrMapOvr>
@@ -11635,7 +11764,388 @@
       </p:sp>
       <p:sp>
         <p:nvSpPr>
-          <p:cNvPr id="74" name="TextBox 73"/>
+          <p:cNvPr id="74" name="flow 1"/>
+          <p:cNvSpPr/>
+          <p:nvPr/>
+        </p:nvSpPr>
+        <p:spPr>
+          <a:xfrm>
+            <a:off x="365760" y="3200400"/>
+            <a:ext cx="1444752" cy="713232"/>
+          </a:xfrm>
+          <a:prstGeom prst="roundRect">
+            <a:avLst>
+              <a:gd name="adj" fmla="val 8000"/>
+            </a:avLst>
+          </a:prstGeom>
+          <a:solidFill>
+            <a:srgbClr val="FFFFFF"/>
+          </a:solidFill>
+          <a:ln w="12700">
+            <a:solidFill>
+              <a:srgbClr val="DADCE0"/>
+            </a:solidFill>
+          </a:ln>
+          <a:effectLst/>
+        </p:spPr>
+        <p:style>
+          <a:lnRef idx="1">
+            <a:schemeClr val="accent1"/>
+          </a:lnRef>
+          <a:fillRef idx="3">
+            <a:schemeClr val="accent1"/>
+          </a:fillRef>
+          <a:effectRef idx="2">
+            <a:schemeClr val="accent1"/>
+          </a:effectRef>
+          <a:fontRef idx="minor">
+            <a:schemeClr val="lt1"/>
+          </a:fontRef>
+        </p:style>
+        <p:txBody>
+          <a:bodyPr rtlCol="0" anchor="ctr"/>
+          <a:lstStyle/>
+          <a:p>
+            <a:pPr algn="ctr"/>
+          </a:p>
+        </p:txBody>
+      </p:sp>
+      <p:sp>
+        <p:nvSpPr>
+          <p:cNvPr id="75" name="TextBox 74"/>
+          <p:cNvSpPr txBox="1"/>
+          <p:nvPr/>
+        </p:nvSpPr>
+        <p:spPr>
+          <a:xfrm>
+            <a:off x="438912" y="3246120"/>
+            <a:ext cx="1298448" cy="640080"/>
+          </a:xfrm>
+          <a:prstGeom prst="rect">
+            <a:avLst/>
+          </a:prstGeom>
+          <a:noFill/>
+        </p:spPr>
+        <p:txBody>
+          <a:bodyPr wrap="square" anchor="ctr" lIns="36576" rIns="36576" tIns="18288" bIns="18288">
+            <a:spAutoFit/>
+          </a:bodyPr>
+          <a:lstStyle/>
+          <a:p>
+            <a:pPr algn="ctr">
+              <a:spcAft>
+                <a:spcPts val="100"/>
+              </a:spcAft>
+            </a:pPr>
+            <a:r>
+              <a:rPr sz="900" i="0">
+                <a:solidFill>
+                  <a:srgbClr val="1A73E8"/>
+                </a:solidFill>
+                <a:latin typeface="Google Sans Flex SemiBold"/>
+              </a:rPr>
+              <a:t>IN</a:t>
+            </a:r>
+          </a:p>
+          <a:p>
+            <a:pPr algn="ctr">
+              <a:spcAft>
+                <a:spcPts val="100"/>
+              </a:spcAft>
+            </a:pPr>
+            <a:r>
+              <a:rPr sz="1200" i="0">
+                <a:solidFill>
+                  <a:srgbClr val="202124"/>
+                </a:solidFill>
+                <a:latin typeface="Google Sans Flex SemiBold"/>
+              </a:rPr>
+              <a:t>One alert</a:t>
+            </a:r>
+          </a:p>
+        </p:txBody>
+      </p:sp>
+      <p:cxnSp>
+        <p:nvCxnSpPr>
+          <p:cNvPr id="76" name="Connector 75"/>
+          <p:cNvCxnSpPr/>
+          <p:nvPr/>
+        </p:nvCxnSpPr>
+        <p:spPr>
+          <a:xfrm>
+            <a:off x="1828800" y="3557016"/>
+            <a:ext cx="237744" cy="0"/>
+          </a:xfrm>
+          <a:prstGeom prst="line">
+            <a:avLst/>
+          </a:prstGeom>
+          <a:ln w="19050">
+            <a:solidFill>
+              <a:srgbClr val="5F6368"/>
+            </a:solidFill>
+            <a:tailEnd type="triangle"/>
+          </a:ln>
+        </p:spPr>
+        <p:style>
+          <a:lnRef idx="2">
+            <a:schemeClr val="accent1"/>
+          </a:lnRef>
+          <a:fillRef idx="0">
+            <a:schemeClr val="accent1"/>
+          </a:fillRef>
+          <a:effectRef idx="1">
+            <a:schemeClr val="accent1"/>
+          </a:effectRef>
+          <a:fontRef idx="minor">
+            <a:schemeClr val="tx1"/>
+          </a:fontRef>
+        </p:style>
+      </p:cxnSp>
+      <p:sp>
+        <p:nvSpPr>
+          <p:cNvPr id="77" name="flow 2"/>
+          <p:cNvSpPr/>
+          <p:nvPr/>
+        </p:nvSpPr>
+        <p:spPr>
+          <a:xfrm>
+            <a:off x="2084831" y="3200400"/>
+            <a:ext cx="1444752" cy="713232"/>
+          </a:xfrm>
+          <a:prstGeom prst="roundRect">
+            <a:avLst>
+              <a:gd name="adj" fmla="val 8000"/>
+            </a:avLst>
+          </a:prstGeom>
+          <a:solidFill>
+            <a:srgbClr val="FFFFFF"/>
+          </a:solidFill>
+          <a:ln w="12700">
+            <a:solidFill>
+              <a:srgbClr val="DADCE0"/>
+            </a:solidFill>
+          </a:ln>
+          <a:effectLst/>
+        </p:spPr>
+        <p:style>
+          <a:lnRef idx="1">
+            <a:schemeClr val="accent1"/>
+          </a:lnRef>
+          <a:fillRef idx="3">
+            <a:schemeClr val="accent1"/>
+          </a:fillRef>
+          <a:effectRef idx="2">
+            <a:schemeClr val="accent1"/>
+          </a:effectRef>
+          <a:fontRef idx="minor">
+            <a:schemeClr val="lt1"/>
+          </a:fontRef>
+        </p:style>
+        <p:txBody>
+          <a:bodyPr rtlCol="0" anchor="ctr"/>
+          <a:lstStyle/>
+          <a:p>
+            <a:pPr algn="ctr"/>
+          </a:p>
+        </p:txBody>
+      </p:sp>
+      <p:sp>
+        <p:nvSpPr>
+          <p:cNvPr id="78" name="TextBox 77"/>
+          <p:cNvSpPr txBox="1"/>
+          <p:nvPr/>
+        </p:nvSpPr>
+        <p:spPr>
+          <a:xfrm>
+            <a:off x="2157984" y="3246120"/>
+            <a:ext cx="1298448" cy="640080"/>
+          </a:xfrm>
+          <a:prstGeom prst="rect">
+            <a:avLst/>
+          </a:prstGeom>
+          <a:noFill/>
+        </p:spPr>
+        <p:txBody>
+          <a:bodyPr wrap="square" anchor="ctr" lIns="36576" rIns="36576" tIns="18288" bIns="18288">
+            <a:spAutoFit/>
+          </a:bodyPr>
+          <a:lstStyle/>
+          <a:p>
+            <a:pPr algn="ctr">
+              <a:spcAft>
+                <a:spcPts val="100"/>
+              </a:spcAft>
+            </a:pPr>
+            <a:r>
+              <a:rPr sz="900" i="0">
+                <a:solidFill>
+                  <a:srgbClr val="1E8E3E"/>
+                </a:solidFill>
+                <a:latin typeface="Google Sans Flex SemiBold"/>
+              </a:rPr>
+              <a:t>OUT</a:t>
+            </a:r>
+          </a:p>
+          <a:p>
+            <a:pPr algn="ctr">
+              <a:spcAft>
+                <a:spcPts val="100"/>
+              </a:spcAft>
+            </a:pPr>
+            <a:r>
+              <a:rPr sz="1200" i="0">
+                <a:solidFill>
+                  <a:srgbClr val="202124"/>
+                </a:solidFill>
+                <a:latin typeface="Google Sans Flex SemiBold"/>
+              </a:rPr>
+              <a:t>A cited case brief</a:t>
+            </a:r>
+          </a:p>
+        </p:txBody>
+      </p:sp>
+      <p:cxnSp>
+        <p:nvCxnSpPr>
+          <p:cNvPr id="79" name="Connector 78"/>
+          <p:cNvCxnSpPr/>
+          <p:nvPr/>
+        </p:nvCxnSpPr>
+        <p:spPr>
+          <a:xfrm>
+            <a:off x="3547872" y="3557016"/>
+            <a:ext cx="237743" cy="0"/>
+          </a:xfrm>
+          <a:prstGeom prst="line">
+            <a:avLst/>
+          </a:prstGeom>
+          <a:ln w="19050">
+            <a:solidFill>
+              <a:srgbClr val="5F6368"/>
+            </a:solidFill>
+            <a:tailEnd type="triangle"/>
+          </a:ln>
+        </p:spPr>
+        <p:style>
+          <a:lnRef idx="2">
+            <a:schemeClr val="accent1"/>
+          </a:lnRef>
+          <a:fillRef idx="0">
+            <a:schemeClr val="accent1"/>
+          </a:fillRef>
+          <a:effectRef idx="1">
+            <a:schemeClr val="accent1"/>
+          </a:effectRef>
+          <a:fontRef idx="minor">
+            <a:schemeClr val="tx1"/>
+          </a:fontRef>
+        </p:style>
+      </p:cxnSp>
+      <p:sp>
+        <p:nvSpPr>
+          <p:cNvPr id="80" name="flow 3"/>
+          <p:cNvSpPr/>
+          <p:nvPr/>
+        </p:nvSpPr>
+        <p:spPr>
+          <a:xfrm>
+            <a:off x="3803904" y="3200400"/>
+            <a:ext cx="1444752" cy="713232"/>
+          </a:xfrm>
+          <a:prstGeom prst="roundRect">
+            <a:avLst>
+              <a:gd name="adj" fmla="val 8000"/>
+            </a:avLst>
+          </a:prstGeom>
+          <a:solidFill>
+            <a:srgbClr val="FFFFFF"/>
+          </a:solidFill>
+          <a:ln w="12700">
+            <a:solidFill>
+              <a:srgbClr val="DADCE0"/>
+            </a:solidFill>
+          </a:ln>
+          <a:effectLst/>
+        </p:spPr>
+        <p:style>
+          <a:lnRef idx="1">
+            <a:schemeClr val="accent1"/>
+          </a:lnRef>
+          <a:fillRef idx="3">
+            <a:schemeClr val="accent1"/>
+          </a:fillRef>
+          <a:effectRef idx="2">
+            <a:schemeClr val="accent1"/>
+          </a:effectRef>
+          <a:fontRef idx="minor">
+            <a:schemeClr val="lt1"/>
+          </a:fontRef>
+        </p:style>
+        <p:txBody>
+          <a:bodyPr rtlCol="0" anchor="ctr"/>
+          <a:lstStyle/>
+          <a:p>
+            <a:pPr algn="ctr"/>
+          </a:p>
+        </p:txBody>
+      </p:sp>
+      <p:sp>
+        <p:nvSpPr>
+          <p:cNvPr id="81" name="TextBox 80"/>
+          <p:cNvSpPr txBox="1"/>
+          <p:nvPr/>
+        </p:nvSpPr>
+        <p:spPr>
+          <a:xfrm>
+            <a:off x="3877056" y="3246120"/>
+            <a:ext cx="1298448" cy="640080"/>
+          </a:xfrm>
+          <a:prstGeom prst="rect">
+            <a:avLst/>
+          </a:prstGeom>
+          <a:noFill/>
+        </p:spPr>
+        <p:txBody>
+          <a:bodyPr wrap="square" anchor="ctr" lIns="36576" rIns="36576" tIns="18288" bIns="18288">
+            <a:spAutoFit/>
+          </a:bodyPr>
+          <a:lstStyle/>
+          <a:p>
+            <a:pPr algn="ctr">
+              <a:spcAft>
+                <a:spcPts val="100"/>
+              </a:spcAft>
+            </a:pPr>
+            <a:r>
+              <a:rPr sz="900" i="0">
+                <a:solidFill>
+                  <a:srgbClr val="F2A900"/>
+                </a:solidFill>
+                <a:latin typeface="Google Sans Flex SemiBold"/>
+              </a:rPr>
+              <a:t>DECISION</a:t>
+            </a:r>
+          </a:p>
+          <a:p>
+            <a:pPr algn="ctr">
+              <a:spcAft>
+                <a:spcPts val="100"/>
+              </a:spcAft>
+            </a:pPr>
+            <a:r>
+              <a:rPr sz="1200" i="0">
+                <a:solidFill>
+                  <a:srgbClr val="202124"/>
+                </a:solidFill>
+                <a:latin typeface="Google Sans Flex SemiBold"/>
+              </a:rPr>
+              <a:t>The analyst's</a:t>
+            </a:r>
+          </a:p>
+        </p:txBody>
+      </p:sp>
+      <p:sp>
+        <p:nvSpPr>
+          <p:cNvPr id="82" name="TextBox 81"/>
           <p:cNvSpPr txBox="1"/>
           <p:nvPr/>
         </p:nvSpPr>
@@ -12054,7 +12564,7 @@
                 </a:solidFill>
                 <a:latin typeface="Google Sans Flex"/>
               </a:rPr>
-              <a:t>Separates duties: deterministic graph tools decide; Gemini only explains.</a:t>
+              <a:t>Separates duties: graph tools compute, Gemini explains, the analyst judges.</a:t>
             </a:r>
           </a:p>
           <a:p>
@@ -16817,16 +17327,40 @@
           </a:p>
         </p:txBody>
       </p:sp>
-      <p:sp>
-        <p:nvSpPr>
-          <p:cNvPr id="107" name="TextBox 106"/>
+      <p:pic>
+        <p:nvPicPr>
+          <p:cNvPr id="107" name="Picture 106" descr="logo-google-cloud.png"/>
+          <p:cNvPicPr>
+            <a:picLocks noChangeAspect="1"/>
+          </p:cNvPicPr>
+          <p:nvPr/>
+        </p:nvPicPr>
+        <p:blipFill>
+          <a:blip r:embed="rId5"/>
+          <a:stretch>
+            <a:fillRect/>
+          </a:stretch>
+        </p:blipFill>
+        <p:spPr>
+          <a:xfrm>
+            <a:off x="2240280" y="1307592"/>
+            <a:ext cx="329184" cy="329184"/>
+          </a:xfrm>
+          <a:prstGeom prst="rect">
+            <a:avLst/>
+          </a:prstGeom>
+        </p:spPr>
+      </p:pic>
+      <p:sp>
+        <p:nvSpPr>
+          <p:cNvPr id="108" name="TextBox 107"/>
           <p:cNvSpPr txBox="1"/>
           <p:nvPr/>
         </p:nvSpPr>
         <p:spPr>
           <a:xfrm>
-            <a:off x="2240280" y="1261872"/>
-            <a:ext cx="4206240" cy="502920"/>
+            <a:off x="2633472" y="1261872"/>
+            <a:ext cx="3840480" cy="502920"/>
           </a:xfrm>
           <a:prstGeom prst="rect">
             <a:avLst/>
@@ -16874,7 +17408,7 @@
       </p:sp>
       <p:sp>
         <p:nvSpPr>
-          <p:cNvPr id="108" name="layer 1"/>
+          <p:cNvPr id="109" name="layer 1"/>
           <p:cNvSpPr/>
           <p:nvPr/>
         </p:nvSpPr>
@@ -16922,7 +17456,7 @@
       </p:sp>
       <p:sp>
         <p:nvSpPr>
-          <p:cNvPr id="109" name="TextBox 108"/>
+          <p:cNvPr id="110" name="TextBox 109"/>
           <p:cNvSpPr txBox="1"/>
           <p:nvPr/>
         </p:nvSpPr>
@@ -16977,7 +17511,7 @@
       </p:sp>
       <p:sp>
         <p:nvSpPr>
-          <p:cNvPr id="110" name="layer 2"/>
+          <p:cNvPr id="111" name="layer 2"/>
           <p:cNvSpPr/>
           <p:nvPr/>
         </p:nvSpPr>
@@ -17025,7 +17559,7 @@
       </p:sp>
       <p:sp>
         <p:nvSpPr>
-          <p:cNvPr id="111" name="TextBox 110"/>
+          <p:cNvPr id="112" name="TextBox 111"/>
           <p:cNvSpPr txBox="1"/>
           <p:nvPr/>
         </p:nvSpPr>
@@ -17080,7 +17614,7 @@
       </p:sp>
       <p:sp>
         <p:nvSpPr>
-          <p:cNvPr id="112" name="layer 3"/>
+          <p:cNvPr id="113" name="layer 3"/>
           <p:cNvSpPr/>
           <p:nvPr/>
         </p:nvSpPr>
@@ -17128,7 +17662,7 @@
       </p:sp>
       <p:sp>
         <p:nvSpPr>
-          <p:cNvPr id="113" name="TextBox 112"/>
+          <p:cNvPr id="114" name="TextBox 113"/>
           <p:cNvSpPr txBox="1"/>
           <p:nvPr/>
         </p:nvSpPr>
@@ -17183,7 +17717,7 @@
       </p:sp>
       <p:sp>
         <p:nvSpPr>
-          <p:cNvPr id="114" name="layer 4"/>
+          <p:cNvPr id="115" name="layer 4"/>
           <p:cNvSpPr/>
           <p:nvPr/>
         </p:nvSpPr>
@@ -17231,7 +17765,7 @@
       </p:sp>
       <p:sp>
         <p:nvSpPr>
-          <p:cNvPr id="115" name="TextBox 114"/>
+          <p:cNvPr id="116" name="TextBox 115"/>
           <p:cNvSpPr txBox="1"/>
           <p:nvPr/>
         </p:nvSpPr>
@@ -17286,14 +17820,14 @@
       </p:sp>
       <p:sp>
         <p:nvSpPr>
-          <p:cNvPr id="116" name="vertex ai"/>
+          <p:cNvPr id="117" name="vertex ai"/>
           <p:cNvSpPr/>
           <p:nvPr/>
         </p:nvSpPr>
         <p:spPr>
           <a:xfrm>
-            <a:off x="6949440" y="1280160"/>
-            <a:ext cx="1874519" cy="1417320"/>
+            <a:off x="6949440" y="1188720"/>
+            <a:ext cx="1874519" cy="1600200"/>
           </a:xfrm>
           <a:prstGeom prst="roundRect">
             <a:avLst>
@@ -17332,16 +17866,64 @@
           </a:p>
         </p:txBody>
       </p:sp>
-      <p:sp>
-        <p:nvSpPr>
-          <p:cNvPr id="117" name="TextBox 116"/>
+      <p:pic>
+        <p:nvPicPr>
+          <p:cNvPr id="118" name="Picture 117" descr="logo-gemini.png"/>
+          <p:cNvPicPr>
+            <a:picLocks noChangeAspect="1"/>
+          </p:cNvPicPr>
+          <p:nvPr/>
+        </p:nvPicPr>
+        <p:blipFill>
+          <a:blip r:embed="rId6"/>
+          <a:stretch>
+            <a:fillRect/>
+          </a:stretch>
+        </p:blipFill>
+        <p:spPr>
+          <a:xfrm>
+            <a:off x="7562088" y="1261872"/>
+            <a:ext cx="292608" cy="292608"/>
+          </a:xfrm>
+          <a:prstGeom prst="rect">
+            <a:avLst/>
+          </a:prstGeom>
+        </p:spPr>
+      </p:pic>
+      <p:pic>
+        <p:nvPicPr>
+          <p:cNvPr id="119" name="Picture 118" descr="logo-vertex-ai.png"/>
+          <p:cNvPicPr>
+            <a:picLocks noChangeAspect="1"/>
+          </p:cNvPicPr>
+          <p:nvPr/>
+        </p:nvPicPr>
+        <p:blipFill>
+          <a:blip r:embed="rId7"/>
+          <a:stretch>
+            <a:fillRect/>
+          </a:stretch>
+        </p:blipFill>
+        <p:spPr>
+          <a:xfrm>
+            <a:off x="7927848" y="1261872"/>
+            <a:ext cx="292608" cy="292608"/>
+          </a:xfrm>
+          <a:prstGeom prst="rect">
+            <a:avLst/>
+          </a:prstGeom>
+        </p:spPr>
+      </p:pic>
+      <p:sp>
+        <p:nvSpPr>
+          <p:cNvPr id="120" name="TextBox 119"/>
           <p:cNvSpPr txBox="1"/>
           <p:nvPr/>
         </p:nvSpPr>
         <p:spPr>
           <a:xfrm>
-            <a:off x="6995160" y="1353312"/>
-            <a:ext cx="1783080" cy="1280160"/>
+            <a:off x="6995160" y="1591056"/>
+            <a:ext cx="1783080" cy="1188720"/>
           </a:xfrm>
           <a:prstGeom prst="rect">
             <a:avLst/>
@@ -17437,7 +18019,7 @@
       </p:sp>
       <p:cxnSp>
         <p:nvCxnSpPr>
-          <p:cNvPr id="118" name="Connector 117"/>
+          <p:cNvPr id="121" name="Connector 120"/>
           <p:cNvCxnSpPr/>
           <p:nvPr/>
         </p:nvCxnSpPr>
@@ -17473,7 +18055,7 @@
       </p:cxnSp>
       <p:cxnSp>
         <p:nvCxnSpPr>
-          <p:cNvPr id="119" name="Connector 118"/>
+          <p:cNvPr id="122" name="Connector 121"/>
           <p:cNvCxnSpPr/>
           <p:nvPr/>
         </p:nvCxnSpPr>
@@ -17509,7 +18091,7 @@
       </p:cxnSp>
       <p:sp>
         <p:nvSpPr>
-          <p:cNvPr id="120" name="TextBox 119"/>
+          <p:cNvPr id="123" name="TextBox 122"/>
           <p:cNvSpPr txBox="1"/>
           <p:nvPr/>
         </p:nvSpPr>
@@ -17548,7 +18130,7 @@
       </p:sp>
       <p:sp>
         <p:nvSpPr>
-          <p:cNvPr id="121" name="TextBox 120"/>
+          <p:cNvPr id="124" name="TextBox 123"/>
           <p:cNvSpPr txBox="1"/>
           <p:nvPr/>
         </p:nvSpPr>
@@ -17972,7 +18554,7 @@
                           </a:solidFill>
                           <a:latin typeface="Google Sans Flex"/>
                         </a:rPr>
-                        <a:t>Structured JSON briefs; LOW thinking keeps a brief to 5–8 s</a:t>
+                        <a:t>Structured JSON briefs; LOW thinking: a brief in 3–9 s (measured)</a:t>
                       </a:r>
                     </a:p>
                   </a:txBody>

</xml_diff>

<commit_message>
docs(TASK-007): slide 11 shows the measured citation check (47/47) instead of a by-design zero
</commit_message>
<xml_diff>
--- a/submission/TraceGuard-proposal.pptx
+++ b/submission/TraceGuard-proposal.pptx
@@ -7886,7 +7886,7 @@
                 </a:solidFill>
                 <a:latin typeface="Google Sans Flex SemiBold"/>
               </a:rPr>
-              <a:t>0</a:t>
+              <a:t>47 / 47</a:t>
             </a:r>
           </a:p>
         </p:txBody>
@@ -7925,7 +7925,7 @@
                 </a:solidFill>
                 <a:latin typeface="Google Sans Flex"/>
               </a:rPr>
-              <a:t>invented citations shown</a:t>
+              <a:t>citations found in the retrieved</a:t>
             </a:r>
           </a:p>
           <a:p>
@@ -7941,7 +7941,7 @@
                 </a:solidFill>
                 <a:latin typeface="Google Sans Flex"/>
               </a:rPr>
-              <a:t>(blocked by design)</a:t>
+              <a:t>evidence (live C-1 brief, slide 10)</a:t>
             </a:r>
           </a:p>
         </p:txBody>

</xml_diff>